<commit_message>
fix: constrain slide-5 bottom images by height so they stop overflowing
Previously both images were sized by width only.  The daily_profile
plot (10x4 aspect) and correlations plot (8x7 aspect) then rendered
tall enough to spill past the slide bottom edge and get cut off.

Now:
  - both bottom images constrained to height=1.55 in
  - repositioned to fit inside the available 1.9-in vertical slot
    between the content boxes (which end near y=4.9) and the footer
    (which starts at y=7.05)
</commit_message>
<xml_diff>
--- a/presentation/microgrid_paper_progress_short.pptx
+++ b/presentation/microgrid_paper_progress_short.pptx
@@ -6163,8 +6163,8 @@
         </p:blipFill>
         <p:spPr>
           <a:xfrm>
-            <a:off x="640080" y="4754880"/>
-            <a:ext cx="5669280" cy="2267712"/>
+            <a:off x="822960" y="4663440"/>
+            <a:ext cx="3543300" cy="1417320"/>
           </a:xfrm>
           <a:prstGeom prst="rect">
             <a:avLst/>
@@ -6187,8 +6187,8 @@
         </p:blipFill>
         <p:spPr>
           <a:xfrm>
-            <a:off x="6583680" y="4572000"/>
-            <a:ext cx="5120640" cy="4480560"/>
+            <a:off x="8686800" y="4663440"/>
+            <a:ext cx="1619794" cy="1417320"/>
           </a:xfrm>
           <a:prstGeom prst="rect">
             <a:avLst/>

</xml_diff>